<commit_message>
fix: graph and demo
</commit_message>
<xml_diff>
--- a/frontend/public/pitch/pitch-deck.pptx
+++ b/frontend/public/pitch/pitch-deck.pptx
@@ -4783,7 +4783,7 @@
           <p:nvPr/>
         </p:nvPicPr>
         <p:blipFill>
-          <a:blip r:embed="rId3"/>
+          <a:blip r:embed="rId4"/>
           <a:stretch>
             <a:fillRect/>
           </a:stretch>
@@ -10344,14 +10344,14 @@
       </p:sp>
       <p:pic>
         <p:nvPicPr>
-          <p:cNvPr id="25" name="Picture 24" descr="pitch-assets-thumb-graph.png"/>
+          <p:cNvPr id="28" name="Picture 27" descr="pitch-assets-thumb-graph.png"/>
           <p:cNvPicPr>
             <a:picLocks noChangeAspect="1"/>
           </p:cNvPicPr>
           <p:nvPr/>
         </p:nvPicPr>
         <p:blipFill>
-          <a:blip r:embed="rId12"/>
+          <a:blip r:embed="rId13"/>
           <a:stretch>
             <a:fillRect/>
           </a:stretch>
@@ -10373,14 +10373,14 @@
       </p:pic>
       <p:pic>
         <p:nvPicPr>
-          <p:cNvPr id="26" name="Picture 25" descr="image.png"/>
+          <p:cNvPr id="29" name="Picture 28" descr="pitch-assets-thumb-chat.png"/>
           <p:cNvPicPr>
             <a:picLocks noChangeAspect="1"/>
           </p:cNvPicPr>
           <p:nvPr/>
         </p:nvPicPr>
         <p:blipFill>
-          <a:blip r:embed="rId10"/>
+          <a:blip r:embed="rId14"/>
           <a:stretch>
             <a:fillRect/>
           </a:stretch>
@@ -10402,14 +10402,14 @@
       </p:pic>
       <p:pic>
         <p:nvPicPr>
-          <p:cNvPr id="27" name="Picture 26" descr="image.png"/>
+          <p:cNvPr id="30" name="Picture 29" descr="pitch-assets-thumb-impact.png"/>
           <p:cNvPicPr>
             <a:picLocks noChangeAspect="1"/>
           </p:cNvPicPr>
           <p:nvPr/>
         </p:nvPicPr>
         <p:blipFill>
-          <a:blip r:embed="rId11"/>
+          <a:blip r:embed="rId15"/>
           <a:stretch>
             <a:fillRect/>
           </a:stretch>

</xml_diff>

<commit_message>
demo done: setup-aware chat, tracking context in answers, node drawer details, empty-LLM-response fallback, demo screenshots + video, deck live URLs
</commit_message>
<xml_diff>
--- a/frontend/public/pitch/pitch-deck.pptx
+++ b/frontend/public/pitch/pitch-deck.pptx
@@ -2185,7 +2185,7 @@
                 <a:ea typeface="Courier New" pitchFamily="34" charset="-122"/>
                 <a:cs typeface="Courier New" pitchFamily="34" charset="-120"/>
               </a:rPr>
-              <a:t>github.com/&lt;your-handle&gt;/reposcope</a:t>
+              <a:t>github.com/adityapatel5912/RepoScope</a:t>
             </a:r>
             <a:endParaRPr lang="en-US" sz="800" dirty="0"/>
           </a:p>
@@ -2335,7 +2335,7 @@
                 <a:ea typeface="Courier New" pitchFamily="34" charset="-122"/>
                 <a:cs typeface="Courier New" pitchFamily="34" charset="-120"/>
               </a:rPr>
-              <a:t>reposcope.vercel.app</a:t>
+              <a:t>repo-scope-nu.vercel.app</a:t>
             </a:r>
             <a:endParaRPr lang="en-US" sz="800" dirty="0"/>
           </a:p>
@@ -2485,7 +2485,7 @@
                 <a:ea typeface="Courier New" pitchFamily="34" charset="-122"/>
                 <a:cs typeface="Courier New" pitchFamily="34" charset="-120"/>
               </a:rPr>
-              <a:t>youtu.be/&lt;video-id&gt;</a:t>
+              <a:t>youtu.be/ZJ7PMCZRXKY</a:t>
             </a:r>
             <a:endParaRPr lang="en-US" sz="800" dirty="0"/>
           </a:p>
@@ -3939,6 +3939,10 @@
             <a:prstDash val="solid"/>
           </a:ln>
         </p:spPr>
+        <p:txBody>
+          <a:bodyPr/>
+          <a:p/>
+        </p:txBody>
       </p:sp>
       <p:sp>
         <p:nvSpPr>
@@ -3962,6 +3966,10 @@
             <a:prstDash val="solid"/>
           </a:ln>
         </p:spPr>
+        <p:txBody>
+          <a:bodyPr/>
+          <a:p/>
+        </p:txBody>
       </p:sp>
       <p:sp>
         <p:nvSpPr>
@@ -3985,6 +3993,10 @@
             <a:prstDash val="solid"/>
           </a:ln>
         </p:spPr>
+        <p:txBody>
+          <a:bodyPr/>
+          <a:p/>
+        </p:txBody>
       </p:sp>
       <p:sp>
         <p:nvSpPr>

</xml_diff>